<commit_message>
made changes in the ppt
</commit_message>
<xml_diff>
--- a/session21-devops-capstone-final/CampusDesk-Capstone.pptx
+++ b/session21-devops-capstone-final/CampusDesk-Capstone.pptx
@@ -121,34 +121,34 @@
   <p:extLst>
     <p:ext uri="{521415D9-36F7-43E2-AB2F-B90AF26B5E84}">
       <p14:sectionLst xmlns:p14="http://schemas.microsoft.com/office/powerpoint/2010/main">
-        <p14:section name="Opening" id="{aaf26011-ec1b-4990-f4bf-c99f2c35dd89}">
+        <p14:section name="Opening" id="{5a730ca3-0bda-c756-d428-3181963e1571}">
           <p14:sldIdLst>
             <p14:sldId id="256"/>
             <p14:sldId id="257"/>
             <p14:sldId id="258"/>
           </p14:sldIdLst>
         </p14:section>
-        <p14:section name="Build" id="{27dbd0cc-778c-b04d-e79a-4a74f44c81e6}">
+        <p14:section name="Build" id="{aad5b7cc-0d20-d586-3276-293d7340b693}">
           <p14:sldIdLst>
             <p14:sldId id="259"/>
             <p14:sldId id="260"/>
             <p14:sldId id="261"/>
           </p14:sldIdLst>
         </p14:section>
-        <p14:section name="Cloud" id="{9631f799-5b1e-7cd4-50c8-f2285a57aa63}">
+        <p14:section name="Cloud" id="{f7fab4e5-6978-bb28-68ee-b6dad2a7aff5}">
           <p14:sldIdLst>
             <p14:sldId id="262"/>
             <p14:sldId id="263"/>
             <p14:sldId id="264"/>
           </p14:sldIdLst>
         </p14:section>
-        <p14:section name="Findings" id="{a8cda10d-2783-5c7d-f346-3b81ec949218}">
+        <p14:section name="Findings" id="{f1f1f0d2-3184-061e-8d71-6b25560f16d8}">
           <p14:sldIdLst>
             <p14:sldId id="265"/>
             <p14:sldId id="266"/>
           </p14:sldIdLst>
         </p14:section>
-        <p14:section name="Close" id="{f32c517e-323d-2fe5-45e8-5d5dec97f862}">
+        <p14:section name="Close" id="{1a327624-c473-1fc2-0e56-eb0048049000}">
           <p14:sldIdLst>
             <p14:sldId id="267"/>
             <p14:sldId id="268"/>
@@ -2849,7 +2849,7 @@
                   <a:srgbClr val="02C39A"/>
                 </a:solidFill>
               </a:rPr>
-              <a:t>A campus facility issue tracker, taken from laptop to a monitored EKS cluster</a:t>
+              <a:t>A campus facility issue tracker</a:t>
             </a:r>
             <a:endParaRPr lang="en-US" sz="1800" dirty="0"/>
           </a:p>
@@ -2860,10 +2860,10 @@
             <a:r>
               <a:rPr lang="en-US" sz="1400" dirty="0">
                 <a:solidFill>
-                  <a:srgbClr val="5C6B73"/>
-                </a:solidFill>
-              </a:rPr>
-              <a:t>DevOps Capstone  ·  Session 21  ·  Lakshay Jagga</a:t>
+                  <a:srgbClr val="9FB3B8"/>
+                </a:solidFill>
+              </a:rPr>
+              <a:t>DevOps Capstone  ·  Session 21  ·  Lakshay Jagga  ·  24BCS10398</a:t>
             </a:r>
             <a:endParaRPr lang="en-US" sz="1800" dirty="0"/>
           </a:p>

</xml_diff>